<commit_message>
Grid to 2x2 layout + complete F5 full-band column; rebuild Deck 4
- reduction_grid.py: 2x2 panel layout (Empty/F4 top, F5/Sim bottom) instead of
  1x4; larger cells/labels for readability.
- F5 full-band column now filled (1-ant full = 27.3mm, broken; worse than its
  focused 22.4 - same full>focused pattern for reduced hardware).
- Deck 4 grid slide updated to the 2x2 aspect. Only sim 3 GHz (2-5) sub-band
  remains pending (pinned GPU).

Co-Authored-By: Claude Opus 4.8 <noreply@anthropic.com>
</commit_message>
<xml_diff>
--- a/regression_deck/Deck4_Reduction_Results.pptx
+++ b/regression_deck/Deck4_Reduction_Results.pptx
@@ -2562,8 +2562,8 @@
         </p:blipFill>
         <p:spPr>
           <a:xfrm>
-            <a:off x="379476" y="2694214"/>
-            <a:ext cx="11430000" cy="2612571"/>
+            <a:off x="2088533" y="1371600"/>
+            <a:ext cx="8011886" cy="5257800"/>
           </a:xfrm>
           <a:prstGeom prst="rect">
             <a:avLst/>

</xml_diff>